<commit_message>
Practiced file ,csv annd json handling
</commit_message>
<xml_diff>
--- a/PowerBI/Projects/Aero Home/AeroHome_Dashboard_Overview.pptx
+++ b/PowerBI/Projects/Aero Home/AeroHome_Dashboard_Overview.pptx
@@ -4,15 +4,15 @@
   <p:sldMasterIdLst>
     <p:sldMasterId id="2147483648" r:id="rId1"/>
   </p:sldMasterIdLst>
+  <p:notesMasterIdLst>
+    <p:notesMasterId r:id="rId6"/>
+  </p:notesMasterIdLst>
   <p:sldIdLst>
     <p:sldId id="256" r:id="rId2"/>
     <p:sldId id="257" r:id="rId3"/>
     <p:sldId id="258" r:id="rId4"/>
     <p:sldId id="259" r:id="rId5"/>
   </p:sldIdLst>
-  <p:notesMasterIdLst>
-    <p:notesMasterId r:id="rId6"/>
-  </p:notesMasterIdLst>
   <p:sldSz cx="12192000" cy="6858000"/>
   <p:notesSz cx="6858000" cy="12192000"/>
   <p:defaultTextStyle>
@@ -107,6 +107,11 @@
       </a:defRPr>
     </a:lvl9pPr>
   </p:defaultTextStyle>
+  <p:extLst>
+    <p:ext uri="{EFAFB233-063F-42B5-8137-9DF3F51BA10A}">
+      <p15:sldGuideLst xmlns:p15="http://schemas.microsoft.com/office/powerpoint/2012/main"/>
+    </p:ext>
+  </p:extLst>
 </p:presentation>
 </file>
 
@@ -132,234 +137,10 @@
           <a:chExt cx="0" cy="0"/>
         </a:xfrm>
       </p:grpSpPr>
-      <p:sp>
-        <p:nvSpPr>
-          <p:cNvPr id="2" name="Header Placeholder 1"/>
-          <p:cNvSpPr>
-            <a:spLocks noGrp="1"/>
-          </p:cNvSpPr>
-          <p:nvPr>
-            <p:ph type="hdr" sz="quarter"/>
-          </p:nvPr>
-        </p:nvSpPr>
-        <p:spPr>
-          <a:xfrm>
-            <a:off x="0" y="0"/>
-            <a:ext cx="2971800" cy="458788"/>
-          </a:xfrm>
-          <a:prstGeom prst="rect">
-            <a:avLst/>
-          </a:prstGeom>
-        </p:spPr>
-        <p:txBody>
-          <a:bodyPr vert="horz" lIns="91440" tIns="45720" rIns="91440" bIns="45720" rtlCol="0"/>
-          <a:lstStyle>
-            <a:lvl1pPr algn="l">
-              <a:defRPr sz="1200"/>
-            </a:lvl1pPr>
-          </a:lstStyle>
-          <a:p>
-            <a:endParaRPr lang="en-US"/>
-          </a:p>
-        </p:txBody>
-      </p:sp>
-      <p:sp>
-        <p:nvSpPr>
-          <p:cNvPr id="3" name="Date Placeholder 2"/>
-          <p:cNvSpPr>
-            <a:spLocks noGrp="1"/>
-          </p:cNvSpPr>
-          <p:nvPr>
-            <p:ph type="dt" idx="1"/>
-          </p:nvPr>
-        </p:nvSpPr>
-        <p:spPr>
-          <a:xfrm>
-            <a:off x="3884613" y="0"/>
-            <a:ext cx="2971800" cy="458788"/>
-          </a:xfrm>
-          <a:prstGeom prst="rect">
-            <a:avLst/>
-          </a:prstGeom>
-        </p:spPr>
-        <p:txBody>
-          <a:bodyPr vert="horz" lIns="91440" tIns="45720" rIns="91440" bIns="45720" rtlCol="0"/>
-          <a:lstStyle>
-            <a:lvl1pPr algn="r">
-              <a:defRPr sz="1200"/>
-            </a:lvl1pPr>
-          </a:lstStyle>
-          <a:p>
-            <a:fld id="{5282F153-3F37-0F45-9E97-73ACFA13230C}" type="datetimeFigureOut">
-              <a:rPr lang="en-US"/>
-              <a:t>7/23/19</a:t>
-            </a:fld>
-            <a:endParaRPr lang="en-US"/>
-          </a:p>
-        </p:txBody>
-      </p:sp>
-      <p:sp>
-        <p:nvSpPr>
-          <p:cNvPr id="4" name="Slide Image Placeholder 3"/>
-          <p:cNvSpPr>
-            <a:spLocks noGrp="1" noRot="1" noChangeAspect="1"/>
-          </p:cNvSpPr>
-          <p:nvPr>
-            <p:ph type="sldImg" idx="2"/>
-          </p:nvPr>
-        </p:nvSpPr>
-        <p:spPr>
-          <a:xfrm>
-            <a:off x="685800" y="1143000"/>
-            <a:ext cx="5486400" cy="3086100"/>
-          </a:xfrm>
-          <a:prstGeom prst="rect">
-            <a:avLst/>
-          </a:prstGeom>
-          <a:noFill/>
-          <a:ln w="12700">
-            <a:solidFill>
-              <a:prstClr val="black"/>
-            </a:solidFill>
-          </a:ln>
-        </p:spPr>
-        <p:txBody>
-          <a:bodyPr vert="horz" lIns="91440" tIns="45720" rIns="91440" bIns="45720" rtlCol="0" anchor="ctr"/>
-          <a:lstStyle/>
-          <a:p>
-            <a:endParaRPr lang="en-US"/>
-          </a:p>
-        </p:txBody>
-      </p:sp>
-      <p:sp>
-        <p:nvSpPr>
-          <p:cNvPr id="5" name="Notes Placeholder 4"/>
-          <p:cNvSpPr>
-            <a:spLocks noGrp="1"/>
-          </p:cNvSpPr>
-          <p:nvPr>
-            <p:ph type="body" sz="quarter" idx="3"/>
-          </p:nvPr>
-        </p:nvSpPr>
-        <p:spPr>
-          <a:xfrm>
-            <a:off x="685800" y="4400550"/>
-            <a:ext cx="5486400" cy="3600450"/>
-          </a:xfrm>
-          <a:prstGeom prst="rect">
-            <a:avLst/>
-          </a:prstGeom>
-        </p:spPr>
-        <p:txBody>
-          <a:bodyPr vert="horz" lIns="91440" tIns="45720" rIns="91440" bIns="45720" rtlCol="0"/>
-          <a:lstStyle/>
-          <a:p>
-            <a:pPr lvl="0"/>
-            <a:r>
-              <a:rPr lang="en-US"/>
-              <a:t>Click to edit Master text styles</a:t>
-            </a:r>
-          </a:p>
-          <a:p>
-            <a:pPr lvl="1"/>
-            <a:r>
-              <a:rPr lang="en-US"/>
-              <a:t>Second level</a:t>
-            </a:r>
-          </a:p>
-          <a:p>
-            <a:pPr lvl="2"/>
-            <a:r>
-              <a:rPr lang="en-US"/>
-              <a:t>Third level</a:t>
-            </a:r>
-          </a:p>
-          <a:p>
-            <a:pPr lvl="3"/>
-            <a:r>
-              <a:rPr lang="en-US"/>
-              <a:t>Fourth level</a:t>
-            </a:r>
-          </a:p>
-          <a:p>
-            <a:pPr lvl="4"/>
-            <a:r>
-              <a:rPr lang="en-US"/>
-              <a:t>Fifth level</a:t>
-            </a:r>
-          </a:p>
-        </p:txBody>
-      </p:sp>
-      <p:sp>
-        <p:nvSpPr>
-          <p:cNvPr id="6" name="Footer Placeholder 5"/>
-          <p:cNvSpPr>
-            <a:spLocks noGrp="1"/>
-          </p:cNvSpPr>
-          <p:nvPr>
-            <p:ph type="ftr" sz="quarter" idx="4"/>
-          </p:nvPr>
-        </p:nvSpPr>
-        <p:spPr>
-          <a:xfrm>
-            <a:off x="0" y="8685213"/>
-            <a:ext cx="2971800" cy="458787"/>
-          </a:xfrm>
-          <a:prstGeom prst="rect">
-            <a:avLst/>
-          </a:prstGeom>
-        </p:spPr>
-        <p:txBody>
-          <a:bodyPr vert="horz" lIns="91440" tIns="45720" rIns="91440" bIns="45720" rtlCol="0" anchor="b"/>
-          <a:lstStyle>
-            <a:lvl1pPr algn="l">
-              <a:defRPr sz="1200"/>
-            </a:lvl1pPr>
-          </a:lstStyle>
-          <a:p>
-            <a:endParaRPr lang="en-US"/>
-          </a:p>
-        </p:txBody>
-      </p:sp>
-      <p:sp>
-        <p:nvSpPr>
-          <p:cNvPr id="7" name="Slide Number Placeholder 6"/>
-          <p:cNvSpPr>
-            <a:spLocks noGrp="1"/>
-          </p:cNvSpPr>
-          <p:nvPr>
-            <p:ph type="sldNum" sz="quarter" idx="5"/>
-          </p:nvPr>
-        </p:nvSpPr>
-        <p:spPr>
-          <a:xfrm>
-            <a:off x="3884613" y="8685213"/>
-            <a:ext cx="2971800" cy="458787"/>
-          </a:xfrm>
-          <a:prstGeom prst="rect">
-            <a:avLst/>
-          </a:prstGeom>
-        </p:spPr>
-        <p:txBody>
-          <a:bodyPr vert="horz" lIns="91440" tIns="45720" rIns="91440" bIns="45720" rtlCol="0" anchor="b"/>
-          <a:lstStyle>
-            <a:lvl1pPr algn="r">
-              <a:defRPr sz="1200"/>
-            </a:lvl1pPr>
-          </a:lstStyle>
-          <a:p>
-            <a:fld id="{CE5E9CC1-C706-0F49-92D6-E571CC5EEA8F}" type="slidenum">
-              <a:rPr lang="en-US"/>
-              <a:t>‹#›</a:t>
-            </a:fld>
-            <a:endParaRPr lang="en-US"/>
-          </a:p>
-        </p:txBody>
-      </p:sp>
     </p:spTree>
     <p:extLst>
       <p:ext uri="{BB962C8B-B14F-4D97-AF65-F5344CB8AC3E}">
-        <p14:creationId xmlns:p14="http://schemas.microsoft.com/office/powerpoint/2010/main" val="1024086991"/>
+        <p14:creationId xmlns:p14="http://schemas.microsoft.com/office/powerpoint/2010/main" val="1985458621"/>
       </p:ext>
     </p:extLst>
   </p:cSld>
@@ -503,10 +284,6 @@
           <a:bodyPr/>
           <a:lstStyle/>
           <a:p>
-            <a:r>
-              <a:rPr lang="en-US" dirty="0"/>
-              <a:t/>
-            </a:r>
             <a:endParaRPr lang="en-US" dirty="0"/>
           </a:p>
         </p:txBody>
@@ -591,10 +368,6 @@
           <a:bodyPr/>
           <a:lstStyle/>
           <a:p>
-            <a:r>
-              <a:rPr lang="en-US" dirty="0"/>
-              <a:t/>
-            </a:r>
             <a:endParaRPr lang="en-US" dirty="0"/>
           </a:p>
         </p:txBody>
@@ -679,10 +452,6 @@
           <a:bodyPr/>
           <a:lstStyle/>
           <a:p>
-            <a:r>
-              <a:rPr lang="en-US" dirty="0"/>
-              <a:t/>
-            </a:r>
             <a:endParaRPr lang="en-US" dirty="0"/>
           </a:p>
         </p:txBody>
@@ -767,10 +536,6 @@
           <a:bodyPr/>
           <a:lstStyle/>
           <a:p>
-            <a:r>
-              <a:rPr lang="en-US" dirty="0"/>
-              <a:t/>
-            </a:r>
             <a:endParaRPr lang="en-US" dirty="0"/>
           </a:p>
         </p:txBody>
@@ -844,6 +609,11 @@
 <file path=ppt/slideMasters/slideMaster1.xml><?xml version="1.0" encoding="utf-8"?>
 <p:sldMaster xmlns:a="http://schemas.openxmlformats.org/drawingml/2006/main" xmlns:r="http://schemas.openxmlformats.org/officeDocument/2006/relationships" xmlns:p="http://schemas.openxmlformats.org/presentationml/2006/main">
   <p:cSld>
+    <p:bg>
+      <p:bgRef idx="1001">
+        <a:schemeClr val="bg1"/>
+      </p:bgRef>
+    </p:bg>
     <p:spTree>
       <p:nvGrpSpPr>
         <p:cNvPr id="1" name=""/>
@@ -1126,6 +896,7 @@
         <a:solidFill>
           <a:srgbClr val="1E2761"/>
         </a:solidFill>
+        <a:effectLst/>
       </p:bgPr>
     </p:bg>
     <p:spTree>
@@ -1161,6 +932,13 @@
           </a:solidFill>
           <a:ln/>
         </p:spPr>
+        <p:txBody>
+          <a:bodyPr/>
+          <a:lstStyle/>
+          <a:p>
+            <a:endParaRPr lang="en-IN"/>
+          </a:p>
+        </p:txBody>
       </p:sp>
       <p:sp>
         <p:nvSpPr>
@@ -1181,6 +959,13 @@
           </a:solidFill>
           <a:ln/>
         </p:spPr>
+        <p:txBody>
+          <a:bodyPr/>
+          <a:lstStyle/>
+          <a:p>
+            <a:endParaRPr lang="en-IN"/>
+          </a:p>
+        </p:txBody>
       </p:sp>
       <p:sp>
         <p:nvSpPr>
@@ -1203,11 +988,11 @@
           <a:bodyPr wrap="square" lIns="0" tIns="0" rIns="0" bIns="0" rtlCol="0" anchor="ctr"/>
           <a:lstStyle/>
           <a:p>
-            <a:pPr indent="0" marL="0">
-              <a:buNone/>
-            </a:pPr>
-            <a:r>
-              <a:rPr lang="en-US" sz="1300" b="1" spc="300" kern="0" dirty="0">
+            <a:pPr marL="0" indent="0">
+              <a:buNone/>
+            </a:pPr>
+            <a:r>
+              <a:rPr lang="en-US" sz="1300" b="1" kern="0" spc="300" dirty="0">
                 <a:solidFill>
                   <a:srgbClr val="CADCFC"/>
                 </a:solidFill>
@@ -1242,7 +1027,7 @@
           <a:bodyPr wrap="square" lIns="0" tIns="0" rIns="0" bIns="0" rtlCol="0" anchor="ctr"/>
           <a:lstStyle/>
           <a:p>
-            <a:pPr indent="0" marL="0">
+            <a:pPr marL="0" indent="0">
               <a:lnSpc>
                 <a:spcPct val="105000"/>
               </a:lnSpc>
@@ -1262,7 +1047,7 @@
             <a:endParaRPr lang="en-US" sz="4000" dirty="0"/>
           </a:p>
           <a:p>
-            <a:pPr indent="0" marL="0">
+            <a:pPr marL="0" indent="0">
               <a:lnSpc>
                 <a:spcPct val="105000"/>
               </a:lnSpc>
@@ -1305,6 +1090,13 @@
             <a:prstDash val="solid"/>
           </a:ln>
         </p:spPr>
+        <p:txBody>
+          <a:bodyPr/>
+          <a:lstStyle/>
+          <a:p>
+            <a:endParaRPr lang="en-IN"/>
+          </a:p>
+        </p:txBody>
       </p:sp>
       <p:sp>
         <p:nvSpPr>
@@ -1327,7 +1119,7 @@
           <a:bodyPr wrap="square" lIns="0" tIns="0" rIns="0" bIns="0" rtlCol="0" anchor="ctr"/>
           <a:lstStyle/>
           <a:p>
-            <a:pPr indent="0" marL="0">
+            <a:pPr marL="0" indent="0">
               <a:lnSpc>
                 <a:spcPct val="125000"/>
               </a:lnSpc>
@@ -1374,6 +1166,13 @@
             <a:prstDash val="solid"/>
           </a:ln>
         </p:spPr>
+        <p:txBody>
+          <a:bodyPr/>
+          <a:lstStyle/>
+          <a:p>
+            <a:endParaRPr lang="en-IN"/>
+          </a:p>
+        </p:txBody>
       </p:sp>
       <p:sp>
         <p:nvSpPr>
@@ -1394,6 +1193,13 @@
           </a:solidFill>
           <a:ln/>
         </p:spPr>
+        <p:txBody>
+          <a:bodyPr/>
+          <a:lstStyle/>
+          <a:p>
+            <a:endParaRPr lang="en-IN"/>
+          </a:p>
+        </p:txBody>
       </p:sp>
       <p:sp>
         <p:nvSpPr>
@@ -1416,7 +1222,7 @@
           <a:bodyPr wrap="square" lIns="0" tIns="0" rIns="0" bIns="0" rtlCol="0" anchor="ctr"/>
           <a:lstStyle/>
           <a:p>
-            <a:pPr algn="ctr" indent="0" marL="0">
+            <a:pPr marL="0" indent="0" algn="ctr">
               <a:buNone/>
             </a:pPr>
             <a:r>
@@ -1442,7 +1248,7 @@
         </p:nvSpPr>
         <p:spPr>
           <a:xfrm>
-            <a:off x="1554480" y="5349240"/>
+            <a:off x="1572768" y="5715000"/>
             <a:ext cx="3108960" cy="365760"/>
           </a:xfrm>
           <a:prstGeom prst="rect">
@@ -1455,7 +1261,7 @@
           <a:bodyPr wrap="square" lIns="0" tIns="0" rIns="0" bIns="0" rtlCol="0" anchor="ctr"/>
           <a:lstStyle/>
           <a:p>
-            <a:pPr indent="0" marL="0">
+            <a:pPr marL="0" indent="0">
               <a:buNone/>
             </a:pPr>
             <a:r>
@@ -1481,7 +1287,7 @@
         </p:nvSpPr>
         <p:spPr>
           <a:xfrm>
-            <a:off x="1554480" y="5742432"/>
+            <a:off x="1554480" y="5417820"/>
             <a:ext cx="3108960" cy="320040"/>
           </a:xfrm>
           <a:prstGeom prst="rect">
@@ -1494,7 +1300,7 @@
           <a:bodyPr wrap="square" lIns="0" tIns="0" rIns="0" bIns="0" rtlCol="0" anchor="ctr"/>
           <a:lstStyle/>
           <a:p>
-            <a:pPr indent="0" marL="0">
+            <a:pPr marL="0" indent="0">
               <a:buNone/>
             </a:pPr>
             <a:r>
@@ -1528,6 +1334,7 @@
         <a:solidFill>
           <a:srgbClr val="FFFFFF"/>
         </a:solidFill>
+        <a:effectLst/>
       </p:bgPr>
     </p:bg>
     <p:spTree>
@@ -1565,7 +1372,7 @@
           <a:bodyPr wrap="square" lIns="0" tIns="0" rIns="0" bIns="0" rtlCol="0" anchor="ctr"/>
           <a:lstStyle/>
           <a:p>
-            <a:pPr indent="0" marL="0">
+            <a:pPr marL="0" indent="0">
               <a:buNone/>
             </a:pPr>
             <a:r>
@@ -1604,7 +1411,7 @@
           <a:bodyPr wrap="square" lIns="0" tIns="0" rIns="0" bIns="0" rtlCol="0" anchor="ctr"/>
           <a:lstStyle/>
           <a:p>
-            <a:pPr indent="0" marL="0">
+            <a:pPr marL="0" indent="0">
               <a:buNone/>
             </a:pPr>
             <a:r>
@@ -1643,6 +1450,13 @@
           </a:solidFill>
           <a:ln/>
         </p:spPr>
+        <p:txBody>
+          <a:bodyPr/>
+          <a:lstStyle/>
+          <a:p>
+            <a:endParaRPr lang="en-IN"/>
+          </a:p>
+        </p:txBody>
       </p:sp>
       <p:sp>
         <p:nvSpPr>
@@ -1663,6 +1477,13 @@
           </a:solidFill>
           <a:ln/>
         </p:spPr>
+        <p:txBody>
+          <a:bodyPr/>
+          <a:lstStyle/>
+          <a:p>
+            <a:endParaRPr lang="en-IN"/>
+          </a:p>
+        </p:txBody>
       </p:sp>
       <p:sp>
         <p:nvSpPr>
@@ -1685,7 +1506,7 @@
           <a:bodyPr wrap="square" lIns="0" tIns="0" rIns="0" bIns="0" rtlCol="0" anchor="ctr"/>
           <a:lstStyle/>
           <a:p>
-            <a:pPr algn="ctr" indent="0" marL="0">
+            <a:pPr marL="0" indent="0" algn="ctr">
               <a:buNone/>
             </a:pPr>
             <a:r>
@@ -1724,7 +1545,7 @@
           <a:bodyPr wrap="square" lIns="0" tIns="0" rIns="0" bIns="0" rtlCol="0" anchor="ctr"/>
           <a:lstStyle/>
           <a:p>
-            <a:pPr indent="0" marL="0">
+            <a:pPr marL="0" indent="0">
               <a:buNone/>
             </a:pPr>
             <a:r>
@@ -1763,7 +1584,7 @@
           <a:bodyPr wrap="square" lIns="0" tIns="0" rIns="0" bIns="0" rtlCol="0" anchor="ctr"/>
           <a:lstStyle/>
           <a:p>
-            <a:pPr indent="0" marL="0">
+            <a:pPr marL="0" indent="0">
               <a:lnSpc>
                 <a:spcPct val="125000"/>
               </a:lnSpc>
@@ -1803,6 +1624,13 @@
           </a:solidFill>
           <a:ln/>
         </p:spPr>
+        <p:txBody>
+          <a:bodyPr/>
+          <a:lstStyle/>
+          <a:p>
+            <a:endParaRPr lang="en-IN"/>
+          </a:p>
+        </p:txBody>
       </p:sp>
       <p:sp>
         <p:nvSpPr>
@@ -1825,7 +1653,7 @@
           <a:bodyPr wrap="square" lIns="0" tIns="0" rIns="0" bIns="0" rtlCol="0" anchor="ctr"/>
           <a:lstStyle/>
           <a:p>
-            <a:pPr indent="0" marL="0">
+            <a:pPr marL="0" indent="0">
               <a:buNone/>
             </a:pPr>
             <a:r>
@@ -1862,6 +1690,13 @@
           </a:solidFill>
           <a:ln/>
         </p:spPr>
+        <p:txBody>
+          <a:bodyPr/>
+          <a:lstStyle/>
+          <a:p>
+            <a:endParaRPr lang="en-IN"/>
+          </a:p>
+        </p:txBody>
       </p:sp>
       <p:sp>
         <p:nvSpPr>
@@ -1884,7 +1719,7 @@
           <a:bodyPr wrap="square" lIns="0" tIns="0" rIns="0" bIns="0" rtlCol="0" anchor="ctr"/>
           <a:lstStyle/>
           <a:p>
-            <a:pPr indent="0" marL="0">
+            <a:pPr marL="0" indent="0">
               <a:buNone/>
             </a:pPr>
             <a:r>
@@ -1921,6 +1756,13 @@
           </a:solidFill>
           <a:ln/>
         </p:spPr>
+        <p:txBody>
+          <a:bodyPr/>
+          <a:lstStyle/>
+          <a:p>
+            <a:endParaRPr lang="en-IN"/>
+          </a:p>
+        </p:txBody>
       </p:sp>
       <p:sp>
         <p:nvSpPr>
@@ -1943,7 +1785,7 @@
           <a:bodyPr wrap="square" lIns="0" tIns="0" rIns="0" bIns="0" rtlCol="0" anchor="ctr"/>
           <a:lstStyle/>
           <a:p>
-            <a:pPr indent="0" marL="0">
+            <a:pPr marL="0" indent="0">
               <a:buNone/>
             </a:pPr>
             <a:r>
@@ -1980,6 +1822,13 @@
           </a:solidFill>
           <a:ln/>
         </p:spPr>
+        <p:txBody>
+          <a:bodyPr/>
+          <a:lstStyle/>
+          <a:p>
+            <a:endParaRPr lang="en-IN"/>
+          </a:p>
+        </p:txBody>
       </p:sp>
       <p:sp>
         <p:nvSpPr>
@@ -2002,7 +1851,7 @@
           <a:bodyPr wrap="square" lIns="0" tIns="0" rIns="0" bIns="0" rtlCol="0" anchor="ctr"/>
           <a:lstStyle/>
           <a:p>
-            <a:pPr indent="0" marL="0">
+            <a:pPr marL="0" indent="0">
               <a:buNone/>
             </a:pPr>
             <a:r>
@@ -2039,6 +1888,13 @@
           </a:solidFill>
           <a:ln/>
         </p:spPr>
+        <p:txBody>
+          <a:bodyPr/>
+          <a:lstStyle/>
+          <a:p>
+            <a:endParaRPr lang="en-IN"/>
+          </a:p>
+        </p:txBody>
       </p:sp>
       <p:sp>
         <p:nvSpPr>
@@ -2061,7 +1917,7 @@
           <a:bodyPr wrap="square" lIns="0" tIns="0" rIns="0" bIns="0" rtlCol="0" anchor="ctr"/>
           <a:lstStyle/>
           <a:p>
-            <a:pPr indent="0" marL="0">
+            <a:pPr marL="0" indent="0">
               <a:buNone/>
             </a:pPr>
             <a:r>
@@ -2098,6 +1954,13 @@
           </a:solidFill>
           <a:ln/>
         </p:spPr>
+        <p:txBody>
+          <a:bodyPr/>
+          <a:lstStyle/>
+          <a:p>
+            <a:endParaRPr lang="en-IN"/>
+          </a:p>
+        </p:txBody>
       </p:sp>
       <p:sp>
         <p:nvSpPr>
@@ -2120,7 +1983,7 @@
           <a:bodyPr wrap="square" lIns="0" tIns="0" rIns="0" bIns="0" rtlCol="0" anchor="ctr"/>
           <a:lstStyle/>
           <a:p>
-            <a:pPr indent="0" marL="0">
+            <a:pPr marL="0" indent="0">
               <a:buNone/>
             </a:pPr>
             <a:r>
@@ -2159,6 +2022,13 @@
           </a:solidFill>
           <a:ln/>
         </p:spPr>
+        <p:txBody>
+          <a:bodyPr/>
+          <a:lstStyle/>
+          <a:p>
+            <a:endParaRPr lang="en-IN"/>
+          </a:p>
+        </p:txBody>
       </p:sp>
       <p:sp>
         <p:nvSpPr>
@@ -2179,6 +2049,13 @@
           </a:solidFill>
           <a:ln/>
         </p:spPr>
+        <p:txBody>
+          <a:bodyPr/>
+          <a:lstStyle/>
+          <a:p>
+            <a:endParaRPr lang="en-IN"/>
+          </a:p>
+        </p:txBody>
       </p:sp>
       <p:sp>
         <p:nvSpPr>
@@ -2201,7 +2078,7 @@
           <a:bodyPr wrap="square" lIns="0" tIns="0" rIns="0" bIns="0" rtlCol="0" anchor="ctr"/>
           <a:lstStyle/>
           <a:p>
-            <a:pPr algn="ctr" indent="0" marL="0">
+            <a:pPr marL="0" indent="0" algn="ctr">
               <a:buNone/>
             </a:pPr>
             <a:r>
@@ -2240,7 +2117,7 @@
           <a:bodyPr wrap="square" lIns="0" tIns="0" rIns="0" bIns="0" rtlCol="0" anchor="ctr"/>
           <a:lstStyle/>
           <a:p>
-            <a:pPr indent="0" marL="0">
+            <a:pPr marL="0" indent="0">
               <a:buNone/>
             </a:pPr>
             <a:r>
@@ -2279,7 +2156,7 @@
           <a:bodyPr wrap="square" lIns="0" tIns="0" rIns="0" bIns="0" rtlCol="0" anchor="ctr"/>
           <a:lstStyle/>
           <a:p>
-            <a:pPr indent="0" marL="0">
+            <a:pPr marL="0" indent="0">
               <a:lnSpc>
                 <a:spcPct val="120000"/>
               </a:lnSpc>
@@ -2321,7 +2198,7 @@
           <a:bodyPr wrap="square" lIns="0" tIns="0" rIns="0" bIns="0" rtlCol="0" anchor="ctr"/>
           <a:lstStyle/>
           <a:p>
-            <a:pPr indent="0" marL="0">
+            <a:pPr marL="0" indent="0">
               <a:buNone/>
             </a:pPr>
             <a:r>
@@ -2360,7 +2237,7 @@
           <a:bodyPr wrap="square" lIns="0" tIns="0" rIns="0" bIns="0" rtlCol="0" anchor="ctr"/>
           <a:lstStyle/>
           <a:p>
-            <a:pPr indent="0" marL="0">
+            <a:pPr marL="0" indent="0">
               <a:buNone/>
             </a:pPr>
             <a:r>
@@ -2399,7 +2276,7 @@
           <a:bodyPr wrap="square" lIns="0" tIns="0" rIns="0" bIns="0" rtlCol="0" anchor="ctr"/>
           <a:lstStyle/>
           <a:p>
-            <a:pPr indent="0" marL="0">
+            <a:pPr marL="0" indent="0">
               <a:buNone/>
             </a:pPr>
             <a:r>
@@ -2438,7 +2315,7 @@
           <a:bodyPr wrap="square" lIns="0" tIns="0" rIns="0" bIns="0" rtlCol="0" anchor="ctr"/>
           <a:lstStyle/>
           <a:p>
-            <a:pPr indent="0" marL="0">
+            <a:pPr marL="0" indent="0">
               <a:buNone/>
             </a:pPr>
             <a:r>
@@ -2477,7 +2354,7 @@
           <a:bodyPr wrap="square" lIns="0" tIns="0" rIns="0" bIns="0" rtlCol="0" anchor="ctr"/>
           <a:lstStyle/>
           <a:p>
-            <a:pPr indent="0" marL="0">
+            <a:pPr marL="0" indent="0">
               <a:buNone/>
             </a:pPr>
             <a:r>
@@ -2516,7 +2393,7 @@
           <a:bodyPr wrap="square" lIns="0" tIns="0" rIns="0" bIns="0" rtlCol="0" anchor="ctr"/>
           <a:lstStyle/>
           <a:p>
-            <a:pPr indent="0" marL="0">
+            <a:pPr marL="0" indent="0">
               <a:buNone/>
             </a:pPr>
             <a:r>
@@ -2555,7 +2432,7 @@
           <a:bodyPr wrap="square" lIns="0" tIns="0" rIns="0" bIns="0" rtlCol="0" anchor="ctr"/>
           <a:lstStyle/>
           <a:p>
-            <a:pPr indent="0" marL="0">
+            <a:pPr marL="0" indent="0">
               <a:buNone/>
             </a:pPr>
             <a:r>
@@ -2594,7 +2471,7 @@
           <a:bodyPr wrap="square" lIns="0" tIns="0" rIns="0" bIns="0" rtlCol="0" anchor="ctr"/>
           <a:lstStyle/>
           <a:p>
-            <a:pPr indent="0" marL="0">
+            <a:pPr marL="0" indent="0">
               <a:buNone/>
             </a:pPr>
             <a:r>
@@ -2633,7 +2510,7 @@
           <a:bodyPr wrap="square" lIns="0" tIns="0" rIns="0" bIns="0" rtlCol="0" anchor="ctr"/>
           <a:lstStyle/>
           <a:p>
-            <a:pPr indent="0" marL="0">
+            <a:pPr marL="0" indent="0">
               <a:buNone/>
             </a:pPr>
             <a:r>
@@ -2672,7 +2549,7 @@
           <a:bodyPr wrap="square" lIns="0" tIns="0" rIns="0" bIns="0" rtlCol="0" anchor="ctr"/>
           <a:lstStyle/>
           <a:p>
-            <a:pPr indent="0" marL="0">
+            <a:pPr marL="0" indent="0">
               <a:buNone/>
             </a:pPr>
             <a:r>
@@ -2711,7 +2588,7 @@
           <a:bodyPr wrap="square" lIns="0" tIns="0" rIns="0" bIns="0" rtlCol="0" anchor="ctr"/>
           <a:lstStyle/>
           <a:p>
-            <a:pPr indent="0" marL="0">
+            <a:pPr marL="0" indent="0">
               <a:buNone/>
             </a:pPr>
             <a:r>
@@ -2750,7 +2627,7 @@
           <a:bodyPr wrap="square" lIns="0" tIns="0" rIns="0" bIns="0" rtlCol="0" anchor="ctr"/>
           <a:lstStyle/>
           <a:p>
-            <a:pPr indent="0" marL="0">
+            <a:pPr marL="0" indent="0">
               <a:buNone/>
             </a:pPr>
             <a:r>
@@ -2784,6 +2661,7 @@
         <a:solidFill>
           <a:srgbClr val="FFFFFF"/>
         </a:solidFill>
+        <a:effectLst/>
       </p:bgPr>
     </p:bg>
     <p:spTree>
@@ -2821,7 +2699,7 @@
           <a:bodyPr wrap="square" lIns="0" tIns="0" rIns="0" bIns="0" rtlCol="0" anchor="ctr"/>
           <a:lstStyle/>
           <a:p>
-            <a:pPr indent="0" marL="0">
+            <a:pPr marL="0" indent="0">
               <a:buNone/>
             </a:pPr>
             <a:r>
@@ -2860,7 +2738,7 @@
           <a:bodyPr wrap="square" lIns="0" tIns="0" rIns="0" bIns="0" rtlCol="0" anchor="ctr"/>
           <a:lstStyle/>
           <a:p>
-            <a:pPr indent="0" marL="0">
+            <a:pPr marL="0" indent="0">
               <a:buNone/>
             </a:pPr>
             <a:r>
@@ -2899,6 +2777,13 @@
           </a:solidFill>
           <a:ln/>
         </p:spPr>
+        <p:txBody>
+          <a:bodyPr/>
+          <a:lstStyle/>
+          <a:p>
+            <a:endParaRPr lang="en-IN"/>
+          </a:p>
+        </p:txBody>
       </p:sp>
       <p:sp>
         <p:nvSpPr>
@@ -2921,7 +2806,7 @@
           <a:bodyPr wrap="square" lIns="0" tIns="0" rIns="0" bIns="0" rtlCol="0" anchor="ctr"/>
           <a:lstStyle/>
           <a:p>
-            <a:pPr algn="ctr" indent="0" marL="0">
+            <a:pPr marL="0" indent="0" algn="ctr">
               <a:buNone/>
             </a:pPr>
             <a:r>
@@ -2960,7 +2845,7 @@
           <a:bodyPr wrap="square" lIns="0" tIns="0" rIns="0" bIns="0" rtlCol="0" anchor="ctr"/>
           <a:lstStyle/>
           <a:p>
-            <a:pPr algn="ctr" indent="0" marL="0">
+            <a:pPr marL="0" indent="0" algn="ctr">
               <a:lnSpc>
                 <a:spcPct val="105000"/>
               </a:lnSpc>
@@ -2980,7 +2865,7 @@
             <a:endParaRPr lang="en-US" sz="1050" dirty="0"/>
           </a:p>
           <a:p>
-            <a:pPr algn="ctr" indent="0" marL="0">
+            <a:pPr marL="0" indent="0" algn="ctr">
               <a:lnSpc>
                 <a:spcPct val="105000"/>
               </a:lnSpc>
@@ -3022,6 +2907,13 @@
           </a:solidFill>
           <a:ln/>
         </p:spPr>
+        <p:txBody>
+          <a:bodyPr/>
+          <a:lstStyle/>
+          <a:p>
+            <a:endParaRPr lang="en-IN"/>
+          </a:p>
+        </p:txBody>
       </p:sp>
       <p:sp>
         <p:nvSpPr>
@@ -3044,7 +2936,7 @@
           <a:bodyPr wrap="square" lIns="0" tIns="0" rIns="0" bIns="0" rtlCol="0" anchor="ctr"/>
           <a:lstStyle/>
           <a:p>
-            <a:pPr algn="ctr" indent="0" marL="0">
+            <a:pPr marL="0" indent="0" algn="ctr">
               <a:buNone/>
             </a:pPr>
             <a:r>
@@ -3083,7 +2975,7 @@
           <a:bodyPr wrap="square" lIns="0" tIns="0" rIns="0" bIns="0" rtlCol="0" anchor="ctr"/>
           <a:lstStyle/>
           <a:p>
-            <a:pPr algn="ctr" indent="0" marL="0">
+            <a:pPr marL="0" indent="0" algn="ctr">
               <a:lnSpc>
                 <a:spcPct val="105000"/>
               </a:lnSpc>
@@ -3103,7 +2995,7 @@
             <a:endParaRPr lang="en-US" sz="1050" dirty="0"/>
           </a:p>
           <a:p>
-            <a:pPr algn="ctr" indent="0" marL="0">
+            <a:pPr marL="0" indent="0" algn="ctr">
               <a:lnSpc>
                 <a:spcPct val="105000"/>
               </a:lnSpc>
@@ -3145,6 +3037,13 @@
           </a:solidFill>
           <a:ln/>
         </p:spPr>
+        <p:txBody>
+          <a:bodyPr/>
+          <a:lstStyle/>
+          <a:p>
+            <a:endParaRPr lang="en-IN"/>
+          </a:p>
+        </p:txBody>
       </p:sp>
       <p:sp>
         <p:nvSpPr>
@@ -3167,7 +3066,7 @@
           <a:bodyPr wrap="square" lIns="0" tIns="0" rIns="0" bIns="0" rtlCol="0" anchor="ctr"/>
           <a:lstStyle/>
           <a:p>
-            <a:pPr algn="ctr" indent="0" marL="0">
+            <a:pPr marL="0" indent="0" algn="ctr">
               <a:buNone/>
             </a:pPr>
             <a:r>
@@ -3206,7 +3105,7 @@
           <a:bodyPr wrap="square" lIns="0" tIns="0" rIns="0" bIns="0" rtlCol="0" anchor="ctr"/>
           <a:lstStyle/>
           <a:p>
-            <a:pPr algn="ctr" indent="0" marL="0">
+            <a:pPr marL="0" indent="0" algn="ctr">
               <a:lnSpc>
                 <a:spcPct val="105000"/>
               </a:lnSpc>
@@ -3226,7 +3125,7 @@
             <a:endParaRPr lang="en-US" sz="1050" dirty="0"/>
           </a:p>
           <a:p>
-            <a:pPr algn="ctr" indent="0" marL="0">
+            <a:pPr marL="0" indent="0" algn="ctr">
               <a:lnSpc>
                 <a:spcPct val="105000"/>
               </a:lnSpc>
@@ -3268,6 +3167,13 @@
           </a:solidFill>
           <a:ln/>
         </p:spPr>
+        <p:txBody>
+          <a:bodyPr/>
+          <a:lstStyle/>
+          <a:p>
+            <a:endParaRPr lang="en-IN"/>
+          </a:p>
+        </p:txBody>
       </p:sp>
       <p:sp>
         <p:nvSpPr>
@@ -3290,7 +3196,7 @@
           <a:bodyPr wrap="square" lIns="0" tIns="0" rIns="0" bIns="0" rtlCol="0" anchor="ctr"/>
           <a:lstStyle/>
           <a:p>
-            <a:pPr algn="ctr" indent="0" marL="0">
+            <a:pPr marL="0" indent="0" algn="ctr">
               <a:buNone/>
             </a:pPr>
             <a:r>
@@ -3329,7 +3235,7 @@
           <a:bodyPr wrap="square" lIns="0" tIns="0" rIns="0" bIns="0" rtlCol="0" anchor="ctr"/>
           <a:lstStyle/>
           <a:p>
-            <a:pPr algn="ctr" indent="0" marL="0">
+            <a:pPr marL="0" indent="0" algn="ctr">
               <a:lnSpc>
                 <a:spcPct val="105000"/>
               </a:lnSpc>
@@ -3349,7 +3255,7 @@
             <a:endParaRPr lang="en-US" sz="1050" dirty="0"/>
           </a:p>
           <a:p>
-            <a:pPr algn="ctr" indent="0" marL="0">
+            <a:pPr marL="0" indent="0" algn="ctr">
               <a:lnSpc>
                 <a:spcPct val="105000"/>
               </a:lnSpc>
@@ -3391,6 +3297,13 @@
           </a:solidFill>
           <a:ln/>
         </p:spPr>
+        <p:txBody>
+          <a:bodyPr/>
+          <a:lstStyle/>
+          <a:p>
+            <a:endParaRPr lang="en-IN"/>
+          </a:p>
+        </p:txBody>
       </p:sp>
       <p:sp>
         <p:nvSpPr>
@@ -3413,7 +3326,7 @@
           <a:bodyPr wrap="square" lIns="0" tIns="0" rIns="0" bIns="0" rtlCol="0" anchor="ctr"/>
           <a:lstStyle/>
           <a:p>
-            <a:pPr algn="ctr" indent="0" marL="0">
+            <a:pPr marL="0" indent="0" algn="ctr">
               <a:buNone/>
             </a:pPr>
             <a:r>
@@ -3452,7 +3365,7 @@
           <a:bodyPr wrap="square" lIns="0" tIns="0" rIns="0" bIns="0" rtlCol="0" anchor="ctr"/>
           <a:lstStyle/>
           <a:p>
-            <a:pPr algn="ctr" indent="0" marL="0">
+            <a:pPr marL="0" indent="0" algn="ctr">
               <a:lnSpc>
                 <a:spcPct val="105000"/>
               </a:lnSpc>
@@ -3472,7 +3385,7 @@
             <a:endParaRPr lang="en-US" sz="1050" dirty="0"/>
           </a:p>
           <a:p>
-            <a:pPr algn="ctr" indent="0" marL="0">
+            <a:pPr marL="0" indent="0" algn="ctr">
               <a:lnSpc>
                 <a:spcPct val="105000"/>
               </a:lnSpc>
@@ -3512,6 +3425,13 @@
           </a:solidFill>
           <a:ln/>
         </p:spPr>
+        <p:txBody>
+          <a:bodyPr/>
+          <a:lstStyle/>
+          <a:p>
+            <a:endParaRPr lang="en-IN"/>
+          </a:p>
+        </p:txBody>
       </p:sp>
       <p:sp>
         <p:nvSpPr>
@@ -3534,7 +3454,7 @@
           <a:bodyPr wrap="square" lIns="0" tIns="0" rIns="0" bIns="0" rtlCol="0" anchor="ctr"/>
           <a:lstStyle/>
           <a:p>
-            <a:pPr algn="ctr" indent="0" marL="0">
+            <a:pPr marL="0" indent="0" algn="ctr">
               <a:buNone/>
             </a:pPr>
             <a:r>
@@ -3573,7 +3493,7 @@
           <a:bodyPr wrap="square" lIns="0" tIns="0" rIns="0" bIns="0" rtlCol="0" anchor="ctr"/>
           <a:lstStyle/>
           <a:p>
-            <a:pPr indent="0" marL="0">
+            <a:pPr marL="0" indent="0">
               <a:buNone/>
             </a:pPr>
             <a:r>
@@ -3612,7 +3532,7 @@
           <a:bodyPr wrap="square" lIns="0" tIns="0" rIns="0" bIns="0" rtlCol="0" anchor="ctr"/>
           <a:lstStyle/>
           <a:p>
-            <a:pPr indent="0" marL="0">
+            <a:pPr marL="0" indent="0">
               <a:buNone/>
             </a:pPr>
             <a:r>
@@ -3649,6 +3569,13 @@
           </a:solidFill>
           <a:ln/>
         </p:spPr>
+        <p:txBody>
+          <a:bodyPr/>
+          <a:lstStyle/>
+          <a:p>
+            <a:endParaRPr lang="en-IN"/>
+          </a:p>
+        </p:txBody>
       </p:sp>
       <p:sp>
         <p:nvSpPr>
@@ -3671,7 +3598,7 @@
           <a:bodyPr wrap="square" lIns="0" tIns="0" rIns="0" bIns="0" rtlCol="0" anchor="ctr"/>
           <a:lstStyle/>
           <a:p>
-            <a:pPr algn="ctr" indent="0" marL="0">
+            <a:pPr marL="0" indent="0" algn="ctr">
               <a:buNone/>
             </a:pPr>
             <a:r>
@@ -3710,7 +3637,7 @@
           <a:bodyPr wrap="square" lIns="0" tIns="0" rIns="0" bIns="0" rtlCol="0" anchor="ctr"/>
           <a:lstStyle/>
           <a:p>
-            <a:pPr indent="0" marL="0">
+            <a:pPr marL="0" indent="0">
               <a:buNone/>
             </a:pPr>
             <a:r>
@@ -3749,7 +3676,7 @@
           <a:bodyPr wrap="square" lIns="0" tIns="0" rIns="0" bIns="0" rtlCol="0" anchor="ctr"/>
           <a:lstStyle/>
           <a:p>
-            <a:pPr indent="0" marL="0">
+            <a:pPr marL="0" indent="0">
               <a:buNone/>
             </a:pPr>
             <a:r>
@@ -3786,6 +3713,13 @@
           </a:solidFill>
           <a:ln/>
         </p:spPr>
+        <p:txBody>
+          <a:bodyPr/>
+          <a:lstStyle/>
+          <a:p>
+            <a:endParaRPr lang="en-IN"/>
+          </a:p>
+        </p:txBody>
       </p:sp>
       <p:sp>
         <p:nvSpPr>
@@ -3808,7 +3742,7 @@
           <a:bodyPr wrap="square" lIns="0" tIns="0" rIns="0" bIns="0" rtlCol="0" anchor="ctr"/>
           <a:lstStyle/>
           <a:p>
-            <a:pPr algn="ctr" indent="0" marL="0">
+            <a:pPr marL="0" indent="0" algn="ctr">
               <a:buNone/>
             </a:pPr>
             <a:r>
@@ -3847,7 +3781,7 @@
           <a:bodyPr wrap="square" lIns="0" tIns="0" rIns="0" bIns="0" rtlCol="0" anchor="ctr"/>
           <a:lstStyle/>
           <a:p>
-            <a:pPr indent="0" marL="0">
+            <a:pPr marL="0" indent="0">
               <a:buNone/>
             </a:pPr>
             <a:r>
@@ -3886,7 +3820,7 @@
           <a:bodyPr wrap="square" lIns="0" tIns="0" rIns="0" bIns="0" rtlCol="0" anchor="ctr"/>
           <a:lstStyle/>
           <a:p>
-            <a:pPr indent="0" marL="0">
+            <a:pPr marL="0" indent="0">
               <a:buNone/>
             </a:pPr>
             <a:r>
@@ -3923,6 +3857,13 @@
           </a:solidFill>
           <a:ln/>
         </p:spPr>
+        <p:txBody>
+          <a:bodyPr/>
+          <a:lstStyle/>
+          <a:p>
+            <a:endParaRPr lang="en-IN"/>
+          </a:p>
+        </p:txBody>
       </p:sp>
       <p:sp>
         <p:nvSpPr>
@@ -3945,7 +3886,7 @@
           <a:bodyPr wrap="square" lIns="0" tIns="0" rIns="0" bIns="0" rtlCol="0" anchor="ctr"/>
           <a:lstStyle/>
           <a:p>
-            <a:pPr algn="ctr" indent="0" marL="0">
+            <a:pPr marL="0" indent="0" algn="ctr">
               <a:buNone/>
             </a:pPr>
             <a:r>
@@ -3984,7 +3925,7 @@
           <a:bodyPr wrap="square" lIns="0" tIns="0" rIns="0" bIns="0" rtlCol="0" anchor="ctr"/>
           <a:lstStyle/>
           <a:p>
-            <a:pPr indent="0" marL="0">
+            <a:pPr marL="0" indent="0">
               <a:buNone/>
             </a:pPr>
             <a:r>
@@ -4023,7 +3964,7 @@
           <a:bodyPr wrap="square" lIns="0" tIns="0" rIns="0" bIns="0" rtlCol="0" anchor="ctr"/>
           <a:lstStyle/>
           <a:p>
-            <a:pPr indent="0" marL="0">
+            <a:pPr marL="0" indent="0">
               <a:buNone/>
             </a:pPr>
             <a:r>
@@ -4060,6 +4001,13 @@
           </a:solidFill>
           <a:ln/>
         </p:spPr>
+        <p:txBody>
+          <a:bodyPr/>
+          <a:lstStyle/>
+          <a:p>
+            <a:endParaRPr lang="en-IN"/>
+          </a:p>
+        </p:txBody>
       </p:sp>
       <p:sp>
         <p:nvSpPr>
@@ -4082,7 +4030,7 @@
           <a:bodyPr wrap="square" lIns="0" tIns="0" rIns="0" bIns="0" rtlCol="0" anchor="ctr"/>
           <a:lstStyle/>
           <a:p>
-            <a:pPr algn="ctr" indent="0" marL="0">
+            <a:pPr marL="0" indent="0" algn="ctr">
               <a:buNone/>
             </a:pPr>
             <a:r>
@@ -4121,7 +4069,7 @@
           <a:bodyPr wrap="square" lIns="0" tIns="0" rIns="0" bIns="0" rtlCol="0" anchor="ctr"/>
           <a:lstStyle/>
           <a:p>
-            <a:pPr indent="0" marL="0">
+            <a:pPr marL="0" indent="0">
               <a:buNone/>
             </a:pPr>
             <a:r>
@@ -4160,7 +4108,7 @@
           <a:bodyPr wrap="square" lIns="0" tIns="0" rIns="0" bIns="0" rtlCol="0" anchor="ctr"/>
           <a:lstStyle/>
           <a:p>
-            <a:pPr indent="0" marL="0">
+            <a:pPr marL="0" indent="0">
               <a:buNone/>
             </a:pPr>
             <a:r>
@@ -4197,6 +4145,13 @@
           </a:solidFill>
           <a:ln/>
         </p:spPr>
+        <p:txBody>
+          <a:bodyPr/>
+          <a:lstStyle/>
+          <a:p>
+            <a:endParaRPr lang="en-IN"/>
+          </a:p>
+        </p:txBody>
       </p:sp>
       <p:sp>
         <p:nvSpPr>
@@ -4219,7 +4174,7 @@
           <a:bodyPr wrap="square" lIns="0" tIns="0" rIns="0" bIns="0" rtlCol="0" anchor="ctr"/>
           <a:lstStyle/>
           <a:p>
-            <a:pPr algn="ctr" indent="0" marL="0">
+            <a:pPr marL="0" indent="0" algn="ctr">
               <a:buNone/>
             </a:pPr>
             <a:r>
@@ -4258,7 +4213,7 @@
           <a:bodyPr wrap="square" lIns="0" tIns="0" rIns="0" bIns="0" rtlCol="0" anchor="ctr"/>
           <a:lstStyle/>
           <a:p>
-            <a:pPr indent="0" marL="0">
+            <a:pPr marL="0" indent="0">
               <a:buNone/>
             </a:pPr>
             <a:r>
@@ -4297,7 +4252,7 @@
           <a:bodyPr wrap="square" lIns="0" tIns="0" rIns="0" bIns="0" rtlCol="0" anchor="ctr"/>
           <a:lstStyle/>
           <a:p>
-            <a:pPr indent="0" marL="0">
+            <a:pPr marL="0" indent="0">
               <a:buNone/>
             </a:pPr>
             <a:r>
@@ -4331,6 +4286,7 @@
         <a:solidFill>
           <a:srgbClr val="FFFFFF"/>
         </a:solidFill>
+        <a:effectLst/>
       </p:bgPr>
     </p:bg>
     <p:spTree>
@@ -4368,7 +4324,7 @@
           <a:bodyPr wrap="square" lIns="0" tIns="0" rIns="0" bIns="0" rtlCol="0" anchor="ctr"/>
           <a:lstStyle/>
           <a:p>
-            <a:pPr indent="0" marL="0">
+            <a:pPr marL="0" indent="0">
               <a:buNone/>
             </a:pPr>
             <a:r>
@@ -4407,7 +4363,7 @@
           <a:bodyPr wrap="square" lIns="0" tIns="0" rIns="0" bIns="0" rtlCol="0" anchor="ctr"/>
           <a:lstStyle/>
           <a:p>
-            <a:pPr indent="0" marL="0">
+            <a:pPr marL="0" indent="0">
               <a:buNone/>
             </a:pPr>
             <a:r>
@@ -4446,6 +4402,13 @@
           </a:solidFill>
           <a:ln/>
         </p:spPr>
+        <p:txBody>
+          <a:bodyPr/>
+          <a:lstStyle/>
+          <a:p>
+            <a:endParaRPr lang="en-IN"/>
+          </a:p>
+        </p:txBody>
       </p:sp>
       <p:sp>
         <p:nvSpPr>
@@ -4466,6 +4429,13 @@
           </a:solidFill>
           <a:ln/>
         </p:spPr>
+        <p:txBody>
+          <a:bodyPr/>
+          <a:lstStyle/>
+          <a:p>
+            <a:endParaRPr lang="en-IN"/>
+          </a:p>
+        </p:txBody>
       </p:sp>
       <p:sp>
         <p:nvSpPr>
@@ -4488,7 +4458,7 @@
           <a:bodyPr wrap="square" lIns="0" tIns="0" rIns="0" bIns="0" rtlCol="0" anchor="ctr"/>
           <a:lstStyle/>
           <a:p>
-            <a:pPr algn="ctr" indent="0" marL="0">
+            <a:pPr marL="0" indent="0" algn="ctr">
               <a:buNone/>
             </a:pPr>
             <a:r>
@@ -4527,7 +4497,7 @@
           <a:bodyPr wrap="square" lIns="0" tIns="0" rIns="0" bIns="0" rtlCol="0" anchor="ctr"/>
           <a:lstStyle/>
           <a:p>
-            <a:pPr indent="0" marL="0">
+            <a:pPr marL="0" indent="0">
               <a:lnSpc>
                 <a:spcPct val="115000"/>
               </a:lnSpc>
@@ -4569,6 +4539,13 @@
           </a:solidFill>
           <a:ln/>
         </p:spPr>
+        <p:txBody>
+          <a:bodyPr/>
+          <a:lstStyle/>
+          <a:p>
+            <a:endParaRPr lang="en-IN"/>
+          </a:p>
+        </p:txBody>
       </p:sp>
       <p:sp>
         <p:nvSpPr>
@@ -4589,6 +4566,13 @@
           </a:solidFill>
           <a:ln/>
         </p:spPr>
+        <p:txBody>
+          <a:bodyPr/>
+          <a:lstStyle/>
+          <a:p>
+            <a:endParaRPr lang="en-IN"/>
+          </a:p>
+        </p:txBody>
       </p:sp>
       <p:sp>
         <p:nvSpPr>
@@ -4611,7 +4595,7 @@
           <a:bodyPr wrap="square" lIns="0" tIns="0" rIns="0" bIns="0" rtlCol="0" anchor="ctr"/>
           <a:lstStyle/>
           <a:p>
-            <a:pPr algn="ctr" indent="0" marL="0">
+            <a:pPr marL="0" indent="0" algn="ctr">
               <a:buNone/>
             </a:pPr>
             <a:r>
@@ -4650,7 +4634,7 @@
           <a:bodyPr wrap="square" lIns="0" tIns="0" rIns="0" bIns="0" rtlCol="0" anchor="ctr"/>
           <a:lstStyle/>
           <a:p>
-            <a:pPr indent="0" marL="0">
+            <a:pPr marL="0" indent="0">
               <a:lnSpc>
                 <a:spcPct val="115000"/>
               </a:lnSpc>
@@ -4665,7 +4649,7 @@
                 <a:ea typeface="Calibri" pitchFamily="34" charset="-122"/>
                 <a:cs typeface="Calibri" pitchFamily="34" charset="-120"/>
               </a:rPr>
-              <a:t>Prioritize the downtime reasons identified by the Pareto analysis that account for the greatest lost time.</a:t>
+              <a:t>Prioritize the downtime reasons identified by the analysis that account for the greatest lost time.</a:t>
             </a:r>
             <a:endParaRPr lang="en-US" sz="1150" dirty="0"/>
           </a:p>
@@ -4692,6 +4676,13 @@
           </a:solidFill>
           <a:ln/>
         </p:spPr>
+        <p:txBody>
+          <a:bodyPr/>
+          <a:lstStyle/>
+          <a:p>
+            <a:endParaRPr lang="en-IN"/>
+          </a:p>
+        </p:txBody>
       </p:sp>
       <p:sp>
         <p:nvSpPr>
@@ -4712,6 +4703,13 @@
           </a:solidFill>
           <a:ln/>
         </p:spPr>
+        <p:txBody>
+          <a:bodyPr/>
+          <a:lstStyle/>
+          <a:p>
+            <a:endParaRPr lang="en-IN"/>
+          </a:p>
+        </p:txBody>
       </p:sp>
       <p:sp>
         <p:nvSpPr>
@@ -4734,7 +4732,7 @@
           <a:bodyPr wrap="square" lIns="0" tIns="0" rIns="0" bIns="0" rtlCol="0" anchor="ctr"/>
           <a:lstStyle/>
           <a:p>
-            <a:pPr algn="ctr" indent="0" marL="0">
+            <a:pPr marL="0" indent="0" algn="ctr">
               <a:buNone/>
             </a:pPr>
             <a:r>
@@ -4773,7 +4771,7 @@
           <a:bodyPr wrap="square" lIns="0" tIns="0" rIns="0" bIns="0" rtlCol="0" anchor="ctr"/>
           <a:lstStyle/>
           <a:p>
-            <a:pPr indent="0" marL="0">
+            <a:pPr marL="0" indent="0">
               <a:lnSpc>
                 <a:spcPct val="115000"/>
               </a:lnSpc>
@@ -4815,6 +4813,13 @@
           </a:solidFill>
           <a:ln/>
         </p:spPr>
+        <p:txBody>
+          <a:bodyPr/>
+          <a:lstStyle/>
+          <a:p>
+            <a:endParaRPr lang="en-IN"/>
+          </a:p>
+        </p:txBody>
       </p:sp>
       <p:sp>
         <p:nvSpPr>
@@ -4835,6 +4840,13 @@
           </a:solidFill>
           <a:ln/>
         </p:spPr>
+        <p:txBody>
+          <a:bodyPr/>
+          <a:lstStyle/>
+          <a:p>
+            <a:endParaRPr lang="en-IN"/>
+          </a:p>
+        </p:txBody>
       </p:sp>
       <p:sp>
         <p:nvSpPr>
@@ -4857,7 +4869,7 @@
           <a:bodyPr wrap="square" lIns="0" tIns="0" rIns="0" bIns="0" rtlCol="0" anchor="ctr"/>
           <a:lstStyle/>
           <a:p>
-            <a:pPr algn="ctr" indent="0" marL="0">
+            <a:pPr marL="0" indent="0" algn="ctr">
               <a:buNone/>
             </a:pPr>
             <a:r>
@@ -4896,7 +4908,7 @@
           <a:bodyPr wrap="square" lIns="0" tIns="0" rIns="0" bIns="0" rtlCol="0" anchor="ctr"/>
           <a:lstStyle/>
           <a:p>
-            <a:pPr indent="0" marL="0">
+            <a:pPr marL="0" indent="0">
               <a:lnSpc>
                 <a:spcPct val="115000"/>
               </a:lnSpc>
@@ -4938,6 +4950,13 @@
           </a:solidFill>
           <a:ln/>
         </p:spPr>
+        <p:txBody>
+          <a:bodyPr/>
+          <a:lstStyle/>
+          <a:p>
+            <a:endParaRPr lang="en-IN"/>
+          </a:p>
+        </p:txBody>
       </p:sp>
       <p:sp>
         <p:nvSpPr>
@@ -4958,6 +4977,13 @@
           </a:solidFill>
           <a:ln/>
         </p:spPr>
+        <p:txBody>
+          <a:bodyPr/>
+          <a:lstStyle/>
+          <a:p>
+            <a:endParaRPr lang="en-IN"/>
+          </a:p>
+        </p:txBody>
       </p:sp>
       <p:sp>
         <p:nvSpPr>
@@ -4980,7 +5006,7 @@
           <a:bodyPr wrap="square" lIns="0" tIns="0" rIns="0" bIns="0" rtlCol="0" anchor="ctr"/>
           <a:lstStyle/>
           <a:p>
-            <a:pPr algn="ctr" indent="0" marL="0">
+            <a:pPr marL="0" indent="0" algn="ctr">
               <a:buNone/>
             </a:pPr>
             <a:r>
@@ -5019,7 +5045,7 @@
           <a:bodyPr wrap="square" lIns="0" tIns="0" rIns="0" bIns="0" rtlCol="0" anchor="ctr"/>
           <a:lstStyle/>
           <a:p>
-            <a:pPr indent="0" marL="0">
+            <a:pPr marL="0" indent="0">
               <a:lnSpc>
                 <a:spcPct val="115000"/>
               </a:lnSpc>
@@ -5061,6 +5087,13 @@
           </a:solidFill>
           <a:ln/>
         </p:spPr>
+        <p:txBody>
+          <a:bodyPr/>
+          <a:lstStyle/>
+          <a:p>
+            <a:endParaRPr lang="en-IN"/>
+          </a:p>
+        </p:txBody>
       </p:sp>
       <p:sp>
         <p:nvSpPr>
@@ -5081,6 +5114,13 @@
           </a:solidFill>
           <a:ln/>
         </p:spPr>
+        <p:txBody>
+          <a:bodyPr/>
+          <a:lstStyle/>
+          <a:p>
+            <a:endParaRPr lang="en-IN"/>
+          </a:p>
+        </p:txBody>
       </p:sp>
       <p:sp>
         <p:nvSpPr>
@@ -5103,7 +5143,7 @@
           <a:bodyPr wrap="square" lIns="0" tIns="0" rIns="0" bIns="0" rtlCol="0" anchor="ctr"/>
           <a:lstStyle/>
           <a:p>
-            <a:pPr algn="ctr" indent="0" marL="0">
+            <a:pPr marL="0" indent="0" algn="ctr">
               <a:buNone/>
             </a:pPr>
             <a:r>
@@ -5142,7 +5182,7 @@
           <a:bodyPr wrap="square" lIns="0" tIns="0" rIns="0" bIns="0" rtlCol="0" anchor="ctr"/>
           <a:lstStyle/>
           <a:p>
-            <a:pPr indent="0" marL="0">
+            <a:pPr marL="0" indent="0">
               <a:lnSpc>
                 <a:spcPct val="115000"/>
               </a:lnSpc>
@@ -5184,6 +5224,13 @@
           </a:solidFill>
           <a:ln/>
         </p:spPr>
+        <p:txBody>
+          <a:bodyPr/>
+          <a:lstStyle/>
+          <a:p>
+            <a:endParaRPr lang="en-IN"/>
+          </a:p>
+        </p:txBody>
       </p:sp>
       <p:sp>
         <p:nvSpPr>
@@ -5204,6 +5251,13 @@
           </a:solidFill>
           <a:ln/>
         </p:spPr>
+        <p:txBody>
+          <a:bodyPr/>
+          <a:lstStyle/>
+          <a:p>
+            <a:endParaRPr lang="en-IN"/>
+          </a:p>
+        </p:txBody>
       </p:sp>
       <p:sp>
         <p:nvSpPr>
@@ -5226,7 +5280,7 @@
           <a:bodyPr wrap="square" lIns="0" tIns="0" rIns="0" bIns="0" rtlCol="0" anchor="ctr"/>
           <a:lstStyle/>
           <a:p>
-            <a:pPr algn="ctr" indent="0" marL="0">
+            <a:pPr marL="0" indent="0" algn="ctr">
               <a:buNone/>
             </a:pPr>
             <a:r>
@@ -5265,7 +5319,7 @@
           <a:bodyPr wrap="square" lIns="0" tIns="0" rIns="0" bIns="0" rtlCol="0" anchor="ctr"/>
           <a:lstStyle/>
           <a:p>
-            <a:pPr indent="0" marL="0">
+            <a:pPr marL="0" indent="0">
               <a:lnSpc>
                 <a:spcPct val="115000"/>
               </a:lnSpc>
@@ -5283,45 +5337,6 @@
               <a:t>Continue monitoring Production Attainment % to catch deviations from plan early.</a:t>
             </a:r>
             <a:endParaRPr lang="en-US" sz="1150" dirty="0"/>
-          </a:p>
-        </p:txBody>
-      </p:sp>
-      <p:sp>
-        <p:nvSpPr>
-          <p:cNvPr id="32" name="Text 30"/>
-          <p:cNvSpPr txBox="1"/>
-          <p:nvPr/>
-        </p:nvSpPr>
-        <p:spPr>
-          <a:xfrm>
-            <a:off x="548640" y="6263640"/>
-            <a:ext cx="11064240" cy="365760"/>
-          </a:xfrm>
-          <a:prstGeom prst="rect">
-            <a:avLst/>
-          </a:prstGeom>
-          <a:noFill/>
-          <a:ln/>
-        </p:spPr>
-        <p:txBody>
-          <a:bodyPr wrap="square" lIns="0" tIns="0" rIns="0" bIns="0" rtlCol="0" anchor="ctr"/>
-          <a:lstStyle/>
-          <a:p>
-            <a:pPr algn="ctr" indent="0" marL="0">
-              <a:buNone/>
-            </a:pPr>
-            <a:r>
-              <a:rPr lang="en-US" sz="1100" i="1" dirty="0">
-                <a:solidFill>
-                  <a:srgbClr val="5A6488"/>
-                </a:solidFill>
-                <a:latin typeface="Calibri" pitchFamily="34" charset="0"/>
-                <a:ea typeface="Calibri" pitchFamily="34" charset="-122"/>
-                <a:cs typeface="Calibri" pitchFamily="34" charset="-120"/>
-              </a:rPr>
-              <a:t>Production Plan  →  Shortfall  →  Plant Contribution  →  Downtime  →  Quality  →  Machines  →  Suppliers</a:t>
-            </a:r>
-            <a:endParaRPr lang="en-US" sz="1100" dirty="0"/>
           </a:p>
         </p:txBody>
       </p:sp>
@@ -5626,4 +5641,319 @@
     </a:ext>
   </a:extLst>
 </a:theme>
+</file>
+
+<file path=ppt/theme/theme2.xml><?xml version="1.0" encoding="utf-8"?>
+<a:theme xmlns:a="http://schemas.openxmlformats.org/drawingml/2006/main" name="Office Theme">
+  <a:themeElements>
+    <a:clrScheme name="Office">
+      <a:dk1>
+        <a:sysClr val="windowText" lastClr="000000"/>
+      </a:dk1>
+      <a:lt1>
+        <a:sysClr val="window" lastClr="FFFFFF"/>
+      </a:lt1>
+      <a:dk2>
+        <a:srgbClr val="0E2841"/>
+      </a:dk2>
+      <a:lt2>
+        <a:srgbClr val="E8E8E8"/>
+      </a:lt2>
+      <a:accent1>
+        <a:srgbClr val="156082"/>
+      </a:accent1>
+      <a:accent2>
+        <a:srgbClr val="E97132"/>
+      </a:accent2>
+      <a:accent3>
+        <a:srgbClr val="196B24"/>
+      </a:accent3>
+      <a:accent4>
+        <a:srgbClr val="0F9ED5"/>
+      </a:accent4>
+      <a:accent5>
+        <a:srgbClr val="A02B93"/>
+      </a:accent5>
+      <a:accent6>
+        <a:srgbClr val="4EA72E"/>
+      </a:accent6>
+      <a:hlink>
+        <a:srgbClr val="467886"/>
+      </a:hlink>
+      <a:folHlink>
+        <a:srgbClr val="96607D"/>
+      </a:folHlink>
+    </a:clrScheme>
+    <a:fontScheme name="Office">
+      <a:majorFont>
+        <a:latin typeface="Aptos Display" panose="02110004020202020204"/>
+        <a:ea typeface=""/>
+        <a:cs typeface=""/>
+        <a:font script="Jpan" typeface="游ゴシック Light"/>
+        <a:font script="Hang" typeface="맑은 고딕"/>
+        <a:font script="Hans" typeface="等线 Light"/>
+        <a:font script="Hant" typeface="新細明體"/>
+        <a:font script="Arab" typeface="Times New Roman"/>
+        <a:font script="Hebr" typeface="Times New Roman"/>
+        <a:font script="Thai" typeface="Angsana New"/>
+        <a:font script="Ethi" typeface="Nyala"/>
+        <a:font script="Beng" typeface="Vrinda"/>
+        <a:font script="Gujr" typeface="Shruti"/>
+        <a:font script="Khmr" typeface="MoolBoran"/>
+        <a:font script="Knda" typeface="Tunga"/>
+        <a:font script="Guru" typeface="Raavi"/>
+        <a:font script="Cans" typeface="Euphemia"/>
+        <a:font script="Cher" typeface="Plantagenet Cherokee"/>
+        <a:font script="Yiii" typeface="Microsoft Yi Baiti"/>
+        <a:font script="Tibt" typeface="Microsoft Himalaya"/>
+        <a:font script="Thaa" typeface="MV Boli"/>
+        <a:font script="Deva" typeface="Mangal"/>
+        <a:font script="Telu" typeface="Gautami"/>
+        <a:font script="Taml" typeface="Latha"/>
+        <a:font script="Syrc" typeface="Estrangelo Edessa"/>
+        <a:font script="Orya" typeface="Kalinga"/>
+        <a:font script="Mlym" typeface="Kartika"/>
+        <a:font script="Laoo" typeface="DokChampa"/>
+        <a:font script="Sinh" typeface="Iskoola Pota"/>
+        <a:font script="Mong" typeface="Mongolian Baiti"/>
+        <a:font script="Viet" typeface="Times New Roman"/>
+        <a:font script="Uigh" typeface="Microsoft Uighur"/>
+        <a:font script="Geor" typeface="Sylfaen"/>
+        <a:font script="Armn" typeface="Arial"/>
+        <a:font script="Bugi" typeface="Leelawadee UI"/>
+        <a:font script="Bopo" typeface="Microsoft JhengHei"/>
+        <a:font script="Java" typeface="Javanese Text"/>
+        <a:font script="Lisu" typeface="Segoe UI"/>
+        <a:font script="Mymr" typeface="Myanmar Text"/>
+        <a:font script="Nkoo" typeface="Ebrima"/>
+        <a:font script="Olck" typeface="Nirmala UI"/>
+        <a:font script="Osma" typeface="Ebrima"/>
+        <a:font script="Phag" typeface="Phagspa"/>
+        <a:font script="Syrn" typeface="Estrangelo Edessa"/>
+        <a:font script="Syrj" typeface="Estrangelo Edessa"/>
+        <a:font script="Syre" typeface="Estrangelo Edessa"/>
+        <a:font script="Sora" typeface="Nirmala UI"/>
+        <a:font script="Tale" typeface="Microsoft Tai Le"/>
+        <a:font script="Talu" typeface="Microsoft New Tai Lue"/>
+        <a:font script="Tfng" typeface="Ebrima"/>
+      </a:majorFont>
+      <a:minorFont>
+        <a:latin typeface="Aptos" panose="02110004020202020204"/>
+        <a:ea typeface=""/>
+        <a:cs typeface=""/>
+        <a:font script="Jpan" typeface="游ゴシック"/>
+        <a:font script="Hang" typeface="맑은 고딕"/>
+        <a:font script="Hans" typeface="等线"/>
+        <a:font script="Hant" typeface="新細明體"/>
+        <a:font script="Arab" typeface="Arial"/>
+        <a:font script="Hebr" typeface="Arial"/>
+        <a:font script="Thai" typeface="Cordia New"/>
+        <a:font script="Ethi" typeface="Nyala"/>
+        <a:font script="Beng" typeface="Vrinda"/>
+        <a:font script="Gujr" typeface="Shruti"/>
+        <a:font script="Khmr" typeface="DaunPenh"/>
+        <a:font script="Knda" typeface="Tunga"/>
+        <a:font script="Guru" typeface="Raavi"/>
+        <a:font script="Cans" typeface="Euphemia"/>
+        <a:font script="Cher" typeface="Plantagenet Cherokee"/>
+        <a:font script="Yiii" typeface="Microsoft Yi Baiti"/>
+        <a:font script="Tibt" typeface="Microsoft Himalaya"/>
+        <a:font script="Thaa" typeface="MV Boli"/>
+        <a:font script="Deva" typeface="Mangal"/>
+        <a:font script="Telu" typeface="Gautami"/>
+        <a:font script="Taml" typeface="Latha"/>
+        <a:font script="Syrc" typeface="Estrangelo Edessa"/>
+        <a:font script="Orya" typeface="Kalinga"/>
+        <a:font script="Mlym" typeface="Kartika"/>
+        <a:font script="Laoo" typeface="DokChampa"/>
+        <a:font script="Sinh" typeface="Iskoola Pota"/>
+        <a:font script="Mong" typeface="Mongolian Baiti"/>
+        <a:font script="Viet" typeface="Arial"/>
+        <a:font script="Uigh" typeface="Microsoft Uighur"/>
+        <a:font script="Geor" typeface="Sylfaen"/>
+        <a:font script="Armn" typeface="Arial"/>
+        <a:font script="Bugi" typeface="Leelawadee UI"/>
+        <a:font script="Bopo" typeface="Microsoft JhengHei"/>
+        <a:font script="Java" typeface="Javanese Text"/>
+        <a:font script="Lisu" typeface="Segoe UI"/>
+        <a:font script="Mymr" typeface="Myanmar Text"/>
+        <a:font script="Nkoo" typeface="Ebrima"/>
+        <a:font script="Olck" typeface="Nirmala UI"/>
+        <a:font script="Osma" typeface="Ebrima"/>
+        <a:font script="Phag" typeface="Phagspa"/>
+        <a:font script="Syrn" typeface="Estrangelo Edessa"/>
+        <a:font script="Syrj" typeface="Estrangelo Edessa"/>
+        <a:font script="Syre" typeface="Estrangelo Edessa"/>
+        <a:font script="Sora" typeface="Nirmala UI"/>
+        <a:font script="Tale" typeface="Microsoft Tai Le"/>
+        <a:font script="Talu" typeface="Microsoft New Tai Lue"/>
+        <a:font script="Tfng" typeface="Ebrima"/>
+      </a:minorFont>
+    </a:fontScheme>
+    <a:fmtScheme name="Office">
+      <a:fillStyleLst>
+        <a:solidFill>
+          <a:schemeClr val="phClr"/>
+        </a:solidFill>
+        <a:gradFill rotWithShape="1">
+          <a:gsLst>
+            <a:gs pos="0">
+              <a:schemeClr val="phClr">
+                <a:lumMod val="110000"/>
+                <a:satMod val="105000"/>
+                <a:tint val="67000"/>
+              </a:schemeClr>
+            </a:gs>
+            <a:gs pos="50000">
+              <a:schemeClr val="phClr">
+                <a:lumMod val="105000"/>
+                <a:satMod val="103000"/>
+                <a:tint val="73000"/>
+              </a:schemeClr>
+            </a:gs>
+            <a:gs pos="100000">
+              <a:schemeClr val="phClr">
+                <a:lumMod val="105000"/>
+                <a:satMod val="109000"/>
+                <a:tint val="81000"/>
+              </a:schemeClr>
+            </a:gs>
+          </a:gsLst>
+          <a:lin ang="5400000" scaled="0"/>
+        </a:gradFill>
+        <a:gradFill rotWithShape="1">
+          <a:gsLst>
+            <a:gs pos="0">
+              <a:schemeClr val="phClr">
+                <a:satMod val="103000"/>
+                <a:lumMod val="102000"/>
+                <a:tint val="94000"/>
+              </a:schemeClr>
+            </a:gs>
+            <a:gs pos="50000">
+              <a:schemeClr val="phClr">
+                <a:satMod val="110000"/>
+                <a:lumMod val="100000"/>
+                <a:shade val="100000"/>
+              </a:schemeClr>
+            </a:gs>
+            <a:gs pos="100000">
+              <a:schemeClr val="phClr">
+                <a:lumMod val="99000"/>
+                <a:satMod val="120000"/>
+                <a:shade val="78000"/>
+              </a:schemeClr>
+            </a:gs>
+          </a:gsLst>
+          <a:lin ang="5400000" scaled="0"/>
+        </a:gradFill>
+      </a:fillStyleLst>
+      <a:lnStyleLst>
+        <a:ln w="12700" cap="flat" cmpd="sng" algn="ctr">
+          <a:solidFill>
+            <a:schemeClr val="phClr"/>
+          </a:solidFill>
+          <a:prstDash val="solid"/>
+          <a:miter lim="800000"/>
+        </a:ln>
+        <a:ln w="19050" cap="flat" cmpd="sng" algn="ctr">
+          <a:solidFill>
+            <a:schemeClr val="phClr"/>
+          </a:solidFill>
+          <a:prstDash val="solid"/>
+          <a:miter lim="800000"/>
+        </a:ln>
+        <a:ln w="25400" cap="flat" cmpd="sng" algn="ctr">
+          <a:solidFill>
+            <a:schemeClr val="phClr"/>
+          </a:solidFill>
+          <a:prstDash val="solid"/>
+          <a:miter lim="800000"/>
+        </a:ln>
+      </a:lnStyleLst>
+      <a:effectStyleLst>
+        <a:effectStyle>
+          <a:effectLst/>
+        </a:effectStyle>
+        <a:effectStyle>
+          <a:effectLst/>
+        </a:effectStyle>
+        <a:effectStyle>
+          <a:effectLst>
+            <a:outerShdw blurRad="57150" dist="19050" dir="5400000" algn="ctr" rotWithShape="0">
+              <a:srgbClr val="000000">
+                <a:alpha val="63000"/>
+              </a:srgbClr>
+            </a:outerShdw>
+          </a:effectLst>
+        </a:effectStyle>
+      </a:effectStyleLst>
+      <a:bgFillStyleLst>
+        <a:solidFill>
+          <a:schemeClr val="phClr"/>
+        </a:solidFill>
+        <a:solidFill>
+          <a:schemeClr val="phClr">
+            <a:tint val="95000"/>
+            <a:satMod val="170000"/>
+          </a:schemeClr>
+        </a:solidFill>
+        <a:gradFill rotWithShape="1">
+          <a:gsLst>
+            <a:gs pos="0">
+              <a:schemeClr val="phClr">
+                <a:tint val="93000"/>
+                <a:satMod val="150000"/>
+                <a:shade val="98000"/>
+                <a:lumMod val="102000"/>
+              </a:schemeClr>
+            </a:gs>
+            <a:gs pos="50000">
+              <a:schemeClr val="phClr">
+                <a:tint val="98000"/>
+                <a:satMod val="130000"/>
+                <a:shade val="90000"/>
+                <a:lumMod val="103000"/>
+              </a:schemeClr>
+            </a:gs>
+            <a:gs pos="100000">
+              <a:schemeClr val="phClr">
+                <a:shade val="63000"/>
+                <a:satMod val="120000"/>
+              </a:schemeClr>
+            </a:gs>
+          </a:gsLst>
+          <a:lin ang="5400000" scaled="0"/>
+        </a:gradFill>
+      </a:bgFillStyleLst>
+    </a:fmtScheme>
+  </a:themeElements>
+  <a:objectDefaults>
+    <a:lnDef>
+      <a:spPr/>
+      <a:bodyPr/>
+      <a:lstStyle/>
+      <a:style>
+        <a:lnRef idx="2">
+          <a:schemeClr val="accent1"/>
+        </a:lnRef>
+        <a:fillRef idx="0">
+          <a:schemeClr val="accent1"/>
+        </a:fillRef>
+        <a:effectRef idx="1">
+          <a:schemeClr val="accent1"/>
+        </a:effectRef>
+        <a:fontRef idx="minor">
+          <a:schemeClr val="tx1"/>
+        </a:fontRef>
+      </a:style>
+    </a:lnDef>
+  </a:objectDefaults>
+  <a:extraClrSchemeLst/>
+  <a:extLst>
+    <a:ext uri="{05A4C25C-085E-4340-85A3-A5531E510DB2}">
+      <thm15:themeFamily xmlns:thm15="http://schemas.microsoft.com/office/thememl/2012/main" name="Office Theme" id="{2E142A2C-CD16-42D6-873A-C26D2A0506FA}" vid="{1BDDFF52-6CD6-40A5-AB3C-68EB2F1E4D0A}"/>
+    </a:ext>
+  </a:extLst>
+</a:theme>
 </file>
</xml_diff>